<commit_message>
Team The Coalition: names in the deck, AI use log, problem analysis, PDFs and README
AI_Use_Log 'who can explain it' is filled by role: Nabeel Ali (AI/ML),
Saad Najam and Ayaan Kashif (backend), Hamza Waseem (frontend).

Co-Authored-By: Claude Opus 5.5 <noreply@anthropic.com>
</commit_message>
<xml_diff>
--- a/docs/BijliCast_HackInsight2026.pptx
+++ b/docs/BijliCast_HackInsight2026.pptx
@@ -2681,7 +2681,7 @@
                   <a:schemeClr val="tx1"/>
                 </a:solidFill>
               </a:rPr>
-              <a:t>[Team Name]  |  Data-to-Decision · Energy demand  |  K-Electric &amp; 9 DISCOs</a:t>
+              <a:t>The Coalition  |  Data-to-Decision · Energy demand  |  K-Electric &amp; 9 DISCOs</a:t>
             </a:r>
             <a:endParaRPr lang="en-US" sz="1600" dirty="0"/>
           </a:p>
@@ -3472,7 +3472,7 @@
                   <a:schemeClr val="accent4"/>
                 </a:solidFill>
               </a:rPr>
-              <a:t>[TEAM NAME]</a:t>
+              <a:t>THE COALITION</a:t>
             </a:r>
             <a:endParaRPr lang="en-US" sz="2800" dirty="0"/>
           </a:p>
@@ -3534,7 +3534,7 @@
                   <a:schemeClr val="bg1"/>
                 </a:solidFill>
               </a:rPr>
-              <a:t>AB</a:t>
+              <a:t>NA</a:t>
             </a:r>
             <a:endParaRPr lang="en-US" sz="1600" dirty="0"/>
           </a:p>
@@ -3570,7 +3570,7 @@
                   <a:schemeClr val="bg1"/>
                 </a:solidFill>
               </a:rPr>
-              <a:t>[Member Name]</a:t>
+              <a:t>Nabeel Ali</a:t>
             </a:r>
             <a:endParaRPr lang="en-US" sz="1400" dirty="0"/>
           </a:p>
@@ -3606,7 +3606,7 @@
                   <a:schemeClr val="accent4"/>
                 </a:solidFill>
               </a:rPr>
-              <a:t>[Role | Roll No.]</a:t>
+              <a:t>AI/ML Engineer</a:t>
             </a:r>
             <a:endParaRPr lang="en-US" sz="1200" dirty="0"/>
           </a:p>
@@ -3668,7 +3668,7 @@
                   <a:schemeClr val="bg1"/>
                 </a:solidFill>
               </a:rPr>
-              <a:t>AB</a:t>
+              <a:t>SN</a:t>
             </a:r>
             <a:endParaRPr lang="en-US" sz="1600" dirty="0"/>
           </a:p>
@@ -3704,7 +3704,7 @@
                   <a:schemeClr val="bg1"/>
                 </a:solidFill>
               </a:rPr>
-              <a:t>[Member Name]</a:t>
+              <a:t>Saad Najam</a:t>
             </a:r>
             <a:endParaRPr lang="en-US" sz="1400" dirty="0"/>
           </a:p>
@@ -3740,7 +3740,7 @@
                   <a:schemeClr val="accent4"/>
                 </a:solidFill>
               </a:rPr>
-              <a:t>[Role | Roll No.]</a:t>
+              <a:t>Backend Engineer</a:t>
             </a:r>
             <a:endParaRPr lang="en-US" sz="1200" dirty="0"/>
           </a:p>
@@ -3802,7 +3802,7 @@
                   <a:schemeClr val="bg1"/>
                 </a:solidFill>
               </a:rPr>
-              <a:t>AB</a:t>
+              <a:t>AK</a:t>
             </a:r>
             <a:endParaRPr lang="en-US" sz="1600" dirty="0"/>
           </a:p>
@@ -3838,7 +3838,7 @@
                   <a:schemeClr val="bg1"/>
                 </a:solidFill>
               </a:rPr>
-              <a:t>[Member Name]</a:t>
+              <a:t>Ayaan Kashif</a:t>
             </a:r>
             <a:endParaRPr lang="en-US" sz="1400" dirty="0"/>
           </a:p>
@@ -3874,7 +3874,7 @@
                   <a:schemeClr val="accent4"/>
                 </a:solidFill>
               </a:rPr>
-              <a:t>[Role | Roll No.]</a:t>
+              <a:t>Backend Engineer</a:t>
             </a:r>
             <a:endParaRPr lang="en-US" sz="1200" dirty="0"/>
           </a:p>
@@ -3936,7 +3936,7 @@
                   <a:schemeClr val="bg1"/>
                 </a:solidFill>
               </a:rPr>
-              <a:t>AB</a:t>
+              <a:t>HW</a:t>
             </a:r>
             <a:endParaRPr lang="en-US" sz="1600" dirty="0"/>
           </a:p>
@@ -3972,7 +3972,7 @@
                   <a:schemeClr val="bg1"/>
                 </a:solidFill>
               </a:rPr>
-              <a:t>[Member Name]</a:t>
+              <a:t>Hamza Waseem</a:t>
             </a:r>
             <a:endParaRPr lang="en-US" sz="1400" dirty="0"/>
           </a:p>
@@ -4008,7 +4008,7 @@
                   <a:schemeClr val="accent4"/>
                 </a:solidFill>
               </a:rPr>
-              <a:t>[Role | Roll No.]</a:t>
+              <a:t>Frontend Engineer</a:t>
             </a:r>
             <a:endParaRPr lang="en-US" sz="1200" dirty="0"/>
           </a:p>
@@ -4044,7 +4044,7 @@
                   <a:schemeClr val="bg1"/>
                 </a:solidFill>
               </a:rPr>
-              <a:t>Mentor / Supervisor: [Name]    |    Contact: github.com/nabeelali0707/hack-insight-hacakthon</a:t>
+              <a:t>Contact: github.com/nabeelali0707/hack-insight-hacakthon</a:t>
             </a:r>
             <a:endParaRPr lang="en-US" sz="1400" dirty="0"/>
           </a:p>

</xml_diff>